<commit_message>
Say tournament, not night: not every tournament is in the evening
Every screen, bot reply and group message in all four languages: "Active
tournament", "Courts for this tournament", "Your tournaments", "Tournaments
played"… English "tonight" in the bot is "in this tournament"; PT, UK and ES
already said "today". The organizer deck says it the same way.

Also fixes a duplicate translation key (noNightsYet) that hid the account
page's empty-state text behind the player register's.

Co-Authored-By: Claude Opus 5.5 <noreply@anthropic.com>
Claude-Session: https://claude.ai/code/session_017UZXckFkC5q3PHtmyrSYKC
</commit_message>
<xml_diff>
--- a/docs/deck/out/padel-buddy-for-organizers.pptx
+++ b/docs/deck/out/padel-buddy-for-organizers.pptx
@@ -118,13 +118,13 @@
   <p:extLst>
     <p:ext uri="{521415D9-36F7-43E2-AB2F-B90AF26B5E84}">
       <p14:sectionLst xmlns:p14="http://schemas.microsoft.com/office/powerpoint/2010/main">
-        <p14:section name="Why" id="{e063624a-cf78-ee0a-a587-e483e65a33ad}">
+        <p14:section name="Why" id="{be007bd1-4e57-9da4-45d6-5d759f86d99a}">
           <p14:sldIdLst>
             <p14:sldId id="256"/>
             <p14:sldId id="257"/>
           </p14:sldIdLst>
         </p14:section>
-        <p14:section name="How it works" id="{21cb24d2-2bab-82e2-e51b-abeff6817f2a}">
+        <p14:section name="How it works" id="{9620f992-c5f7-5604-58d9-967b30858072}">
           <p14:sldIdLst>
             <p14:sldId id="258"/>
             <p14:sldId id="259"/>
@@ -132,19 +132,19 @@
             <p14:sldId id="261"/>
           </p14:sldIdLst>
         </p14:section>
-        <p14:section name="For players" id="{e9d45897-298b-b5bd-3f7f-d2d8c2730789}">
+        <p14:section name="For players" id="{90b3cecf-fbaa-a7bb-20c8-e0e6d7ad3359}">
           <p14:sldIdLst>
             <p14:sldId id="262"/>
             <p14:sldId id="263"/>
           </p14:sldIdLst>
         </p14:section>
-        <p14:section name="For the club" id="{816042dc-406b-e2a8-ff90-c529162a77cf}">
+        <p14:section name="For the club" id="{a62bc997-6f74-b66b-7abc-42d84decb60d}">
           <p14:sldIdLst>
             <p14:sldId id="264"/>
             <p14:sldId id="265"/>
           </p14:sldIdLst>
         </p14:section>
-        <p14:section name="Next" id="{75f73814-5333-b77e-525e-49847c919b9b}">
+        <p14:section name="Next" id="{c06c6ba5-fb18-4c26-c4ae-52e62df9814f}">
           <p14:sldIdLst>
             <p14:sldId id="266"/>
             <p14:sldId id="267"/>
@@ -554,7 +554,7 @@
           <a:p>
             <a:r>
               <a:rPr lang="en-US" dirty="0"/>
-              <a:t>Padel Buddy Tournaments runs a club's tournament nights: sign-ups, pairs, the schedule, scores, standings, and the messages to the group. Everything in this deck is the real app; the players are invented.</a:t>
+              <a:t>Padel Buddy Tournaments runs a club's tournaments, morning or evening: sign-ups, pairs, the schedule, scores, standings, and the messages to the group. Everything in this deck is the real app; the players are invented.</a:t>
             </a:r>
             <a:endParaRPr lang="en-US" dirty="0"/>
           </a:p>
@@ -642,7 +642,7 @@
           <a:p>
             <a:r>
               <a:rPr lang="en-US" dirty="0"/>
-              <a:t>The details that make it fit a real club: languages, phones, both chat apps, several venues, courts that change from night to night, and standings ready to share.</a:t>
+              <a:t>The details that make it fit a real club: languages, phones, both chat apps, several venues, courts that change from one tournament to the next, and standings ready to share.</a:t>
             </a:r>
             <a:endParaRPr lang="en-US" dirty="0"/>
           </a:p>
@@ -994,7 +994,7 @@
           <a:p>
             <a:r>
               <a:rPr lang="en-US" dirty="0"/>
-              <a:t>Four steps. Paste and Pair happen before the night; Play and Post happen during it, and Post is automatic: the last score of a round sends the next round to the group.</a:t>
+              <a:t>Four steps. Paste and Pair happen before the tournament; Play and Post happen during it, and Post is automatic: the last score of a round sends the next round to the group.</a:t>
             </a:r>
             <a:endParaRPr lang="en-US" dirty="0"/>
           </a:p>
@@ -1082,7 +1082,7 @@
           <a:p>
             <a:r>
               <a:rPr lang="en-US" dirty="0"/>
-              <a:t>Clip: the organizer pastes the club's usual WhatsApp message, presses Read the message, checks what was understood, and creates the night with all eight players signed up.</a:t>
+              <a:t>Clip: the organizer pastes the club's usual WhatsApp message, presses Read the message, checks what was understood, and creates the tournament with all eight players signed up.</a:t>
             </a:r>
             <a:endParaRPr lang="en-US" dirty="0"/>
           </a:p>
@@ -2325,7 +2325,7 @@
                   <a:srgbClr val="E7EDF5"/>
                 </a:solidFill>
               </a:rPr>
-              <a:t>Run your padel nights from the group chat</a:t>
+              <a:t>Run your padel tournaments from the group chat</a:t>
             </a:r>
             <a:endParaRPr lang="en-US" sz="4400" dirty="0"/>
           </a:p>
@@ -3246,7 +3246,7 @@
                   <a:srgbClr val="E7EDF5"/>
                 </a:solidFill>
               </a:rPr>
-              <a:t>Courts per night</a:t>
+              <a:t>Courts per tournament</a:t>
             </a:r>
             <a:endParaRPr lang="en-US" sz="1800" dirty="0"/>
           </a:p>
@@ -3282,7 +3282,7 @@
                   <a:srgbClr val="9AA4B2"/>
                 </a:solidFill>
               </a:rPr>
-              <a:t>Name them, add or remove them for one night without touching the next.</a:t>
+              <a:t>Name them, add or remove them for one tournament without touching the next.</a:t>
             </a:r>
             <a:endParaRPr lang="en-US" sz="1400" dirty="0"/>
           </a:p>
@@ -4270,7 +4270,7 @@
                   <a:srgbClr val="E7EDF5"/>
                 </a:solidFill>
               </a:rPr>
-              <a:t>Your next night, without the paper</a:t>
+              <a:t>Your next tournament, without the paper</a:t>
             </a:r>
             <a:endParaRPr lang="en-US" sz="4400" dirty="0"/>
           </a:p>
@@ -4487,7 +4487,7 @@
                   <a:srgbClr val="E7EDF5"/>
                 </a:solidFill>
               </a:rPr>
-              <a:t>Every night, the same admin</a:t>
+              <a:t>Every tournament, the same admin</a:t>
             </a:r>
             <a:endParaRPr lang="en-US" sz="3400" dirty="0"/>
           </a:p>
@@ -4523,7 +4523,7 @@
                   <a:srgbClr val="9AA4B2"/>
                 </a:solidFill>
               </a:rPr>
-              <a:t>What a nonstop or Americano night costs the organizer today</a:t>
+              <a:t>What a nonstop or Americano tournament costs the organizer today</a:t>
             </a:r>
             <a:endParaRPr lang="en-US" sz="1600" dirty="0"/>
           </a:p>
@@ -5115,7 +5115,7 @@
                   <a:srgbClr val="9AA4B2"/>
                 </a:solidFill>
               </a:rPr>
-              <a:t>Adding up points after the night, then a PDF in the group the next day.</a:t>
+              <a:t>Adding up points afterwards, then a PDF in the group the next day.</a:t>
             </a:r>
             <a:endParaRPr lang="en-US" sz="1500" dirty="0"/>
           </a:p>
@@ -5223,7 +5223,7 @@
                   <a:srgbClr val="E7EDF5"/>
                 </a:solidFill>
               </a:rPr>
-              <a:t>A night in four steps</a:t>
+              <a:t>A tournament in four steps</a:t>
             </a:r>
             <a:endParaRPr lang="en-US" sz="3400" dirty="0"/>
           </a:p>
@@ -6331,7 +6331,7 @@
                   <a:srgbClr val="E7EDF5"/>
                 </a:solidFill>
               </a:rPr>
-              <a:t>One tap creates the night</a:t>
+              <a:t>One tap creates the tournament</a:t>
             </a:r>
             <a:endParaRPr lang="en-US" sz="1600" dirty="0"/>
           </a:p>
@@ -6670,7 +6670,7 @@
                   <a:srgbClr val="9AA4B2"/>
                 </a:solidFill>
               </a:rPr>
-              <a:t>Fills every empty seat; on a mixed night, one of each per pair.</a:t>
+              <a:t>Fills every empty seat; on a mixed level, one of each per pair.</a:t>
             </a:r>
             <a:endParaRPr lang="en-US" sz="1600" dirty="0"/>
           </a:p>
@@ -8318,7 +8318,7 @@
                   <a:srgbClr val="9AA4B2"/>
                 </a:solidFill>
               </a:rPr>
-              <a:t>A 1 to 7 level per player. Each change is kept with its date and a note: "won three nights running".</a:t>
+              <a:t>A 1 to 7 level per player. Each change is kept with its date and a note: "won three tournaments running".</a:t>
             </a:r>
             <a:endParaRPr lang="en-US" sz="1600" dirty="0"/>
           </a:p>
@@ -8332,7 +8332,7 @@
                   <a:srgbClr val="E7EDF5"/>
                 </a:solidFill>
               </a:rPr>
-              <a:t>Used on the night</a:t>
+              <a:t>Used on the day</a:t>
             </a:r>
             <a:endParaRPr lang="en-US" sz="1600" dirty="0"/>
           </a:p>

</xml_diff>